<commit_message>
SARSA/Q-learning convergence on slippery grid, policy iteration, docs
- Optional per-visit step size alpha/(1+k*N(s,a)) (Robbins-Monro) for
  SARSA, Q-learning and Expected SARSA
- exp1: convergent schedule (GLIE eps->0 + decaying alpha) reaches the
  optimal policy in 20/20 seeds for both SARSA and Q-learning
- Policy iteration in dp.py, with a test against value iteration
- README: convergent schedule, Optuna/SARSA explanation, small fixes
- THEORY.md: GLIE result, VI vs PI, section on extras beyond class
- Slides: updated results and two backup slides
</commit_message>
<xml_diff>
--- a/docs/presentation.pptx
+++ b/docs/presentation.pptx
@@ -13,6 +13,8 @@
     <p:sldId id="261" r:id="rId12"/>
     <p:sldId id="262" r:id="rId13"/>
     <p:sldId id="263" r:id="rId14"/>
+    <p:sldId id="264" r:id="rId15"/>
+    <p:sldId id="265" r:id="rId16"/>
   </p:sldIdLst>
   <p:sldSz cx="12191695" cy="6858000" type="screen4x3"/>
   <p:notesSz cx="6858000" cy="9144000"/>
@@ -3217,6 +3219,256 @@
 </p:sld>
 </file>
 
+<file path=ppt/slides/slide10.xml><?xml version="1.0" encoding="utf-8"?>
+<p:sld xmlns:a="http://schemas.openxmlformats.org/drawingml/2006/main" xmlns:p="http://schemas.openxmlformats.org/presentationml/2006/main" xmlns:r="http://schemas.openxmlformats.org/officeDocument/2006/relationships">
+  <p:cSld>
+    <p:spTree>
+      <p:nvGrpSpPr>
+        <p:cNvPr id="1" name=""/>
+        <p:cNvGrpSpPr/>
+        <p:nvPr/>
+      </p:nvGrpSpPr>
+      <p:grpSpPr/>
+      <p:sp>
+        <p:nvSpPr>
+          <p:cNvPr id="2" name="Rectangle 1"/>
+          <p:cNvSpPr/>
+          <p:nvPr/>
+        </p:nvSpPr>
+        <p:spPr>
+          <a:xfrm>
+            <a:off x="0" y="0"/>
+            <a:ext cx="12191695" cy="109728"/>
+          </a:xfrm>
+          <a:prstGeom prst="rect">
+            <a:avLst/>
+          </a:prstGeom>
+          <a:solidFill>
+            <a:srgbClr val="D55E00"/>
+          </a:solidFill>
+          <a:ln>
+            <a:noFill/>
+          </a:ln>
+        </p:spPr>
+        <p:style>
+          <a:lnRef idx="1">
+            <a:schemeClr val="accent1"/>
+          </a:lnRef>
+          <a:fillRef idx="3">
+            <a:schemeClr val="accent1"/>
+          </a:fillRef>
+          <a:effectRef idx="2">
+            <a:schemeClr val="accent1"/>
+          </a:effectRef>
+          <a:fontRef idx="minor">
+            <a:schemeClr val="lt1"/>
+          </a:fontRef>
+        </p:style>
+        <p:txBody>
+          <a:bodyPr rtlCol="0" anchor="ctr"/>
+          <a:lstStyle/>
+          <a:p>
+            <a:pPr algn="ctr"/>
+          </a:p>
+        </p:txBody>
+      </p:sp>
+      <p:sp>
+        <p:nvSpPr>
+          <p:cNvPr id="3" name="TextBox 2"/>
+          <p:cNvSpPr txBox="1"/>
+          <p:nvPr/>
+        </p:nvSpPr>
+        <p:spPr>
+          <a:xfrm>
+            <a:off x="457200" y="228600"/>
+            <a:ext cx="11247120" cy="640080"/>
+          </a:xfrm>
+          <a:prstGeom prst="rect">
+            <a:avLst/>
+          </a:prstGeom>
+          <a:noFill/>
+        </p:spPr>
+        <p:txBody>
+          <a:bodyPr wrap="square">
+            <a:spAutoFit/>
+          </a:bodyPr>
+          <a:lstStyle/>
+          <a:p>
+            <a:pPr>
+              <a:spcAft>
+                <a:spcPts val="600"/>
+              </a:spcAft>
+              <a:defRPr sz="2800" b="1">
+                <a:solidFill>
+                  <a:srgbClr val="1F2A44"/>
+                </a:solidFill>
+              </a:defRPr>
+            </a:pPr>
+            <a:r>
+              <a:t>Backup: extras beyond the class slides</a:t>
+            </a:r>
+          </a:p>
+        </p:txBody>
+      </p:sp>
+      <p:sp>
+        <p:nvSpPr>
+          <p:cNvPr id="4" name="TextBox 3"/>
+          <p:cNvSpPr txBox="1"/>
+          <p:nvPr/>
+        </p:nvSpPr>
+        <p:spPr>
+          <a:xfrm>
+            <a:off x="457200" y="822960"/>
+            <a:ext cx="11247120" cy="457200"/>
+          </a:xfrm>
+          <a:prstGeom prst="rect">
+            <a:avLst/>
+          </a:prstGeom>
+          <a:noFill/>
+        </p:spPr>
+        <p:txBody>
+          <a:bodyPr wrap="square">
+            <a:spAutoFit/>
+          </a:bodyPr>
+          <a:lstStyle/>
+          <a:p>
+            <a:pPr>
+              <a:spcAft>
+                <a:spcPts val="600"/>
+              </a:spcAft>
+              <a:defRPr sz="1500" b="0">
+                <a:solidFill>
+                  <a:srgbClr val="555B66"/>
+                </a:solidFill>
+              </a:defRPr>
+            </a:pPr>
+            <a:r>
+              <a:t>Each one is a small change to an algorithm seen in class</a:t>
+            </a:r>
+          </a:p>
+        </p:txBody>
+      </p:sp>
+      <p:sp>
+        <p:nvSpPr>
+          <p:cNvPr id="5" name="TextBox 4"/>
+          <p:cNvSpPr txBox="1"/>
+          <p:nvPr/>
+        </p:nvSpPr>
+        <p:spPr>
+          <a:xfrm>
+            <a:off x="640080" y="1371600"/>
+            <a:ext cx="10972800" cy="5029200"/>
+          </a:xfrm>
+          <a:prstGeom prst="rect">
+            <a:avLst/>
+          </a:prstGeom>
+          <a:noFill/>
+        </p:spPr>
+        <p:txBody>
+          <a:bodyPr wrap="square">
+            <a:spAutoFit/>
+          </a:bodyPr>
+          <a:lstStyle/>
+          <a:p>
+            <a:pPr>
+              <a:spcAft>
+                <a:spcPts val="600"/>
+              </a:spcAft>
+              <a:defRPr sz="2000" b="0">
+                <a:solidFill>
+                  <a:srgbClr val="1F2A44"/>
+                </a:solidFill>
+              </a:defRPr>
+            </a:pPr>
+            <a:r>
+              <a:t>• Expected SARSA: target r + γ Σ π(a'|s') Q(s',a')  (Bellman eq. (3) inside the TD target, lower variance)</a:t>
+            </a:r>
+          </a:p>
+          <a:p>
+            <a:pPr>
+              <a:spcAft>
+                <a:spcPts val="600"/>
+              </a:spcAft>
+              <a:defRPr sz="2000" b="0">
+                <a:solidFill>
+                  <a:srgbClr val="1F2A44"/>
+                </a:solidFill>
+              </a:defRPr>
+            </a:pPr>
+            <a:r>
+              <a:t>• Double Q-learning: two tables, one picks argmax, the other evaluates it  (removes the max over-estimation)</a:t>
+            </a:r>
+          </a:p>
+          <a:p>
+            <a:pPr>
+              <a:spcAft>
+                <a:spcPts val="600"/>
+              </a:spcAft>
+              <a:defRPr sz="2000" b="0">
+                <a:solidFill>
+                  <a:srgbClr val="1F2A44"/>
+                </a:solidFill>
+              </a:defRPr>
+            </a:pPr>
+            <a:r>
+              <a:t>• n-step SARSA: n = 1 → SARSA, n → ∞ → Monte Carlo</a:t>
+            </a:r>
+          </a:p>
+          <a:p>
+            <a:pPr>
+              <a:spcAft>
+                <a:spcPts val="600"/>
+              </a:spcAft>
+              <a:defRPr sz="2000" b="0">
+                <a:solidFill>
+                  <a:srgbClr val="1F2A44"/>
+                </a:solidFill>
+              </a:defRPr>
+            </a:pPr>
+            <a:r>
+              <a:t>• Regret = V*(s0) − V^π(s0), computed exactly with the model</a:t>
+            </a:r>
+          </a:p>
+          <a:p>
+            <a:pPr>
+              <a:spcAft>
+                <a:spcPts val="600"/>
+              </a:spcAft>
+              <a:defRPr sz="2000" b="0">
+                <a:solidFill>
+                  <a:srgbClr val="1F2A44"/>
+                </a:solidFill>
+              </a:defRPr>
+            </a:pPr>
+            <a:r>
+              <a:t>• α(s,a) = α/(1+k·N(s,a)): Robbins–Monro; MC's online mean is the case α = 1/N</a:t>
+            </a:r>
+          </a:p>
+          <a:p>
+            <a:pPr>
+              <a:spcAft>
+                <a:spcPts val="600"/>
+              </a:spcAft>
+              <a:defRPr sz="2000" b="0">
+                <a:solidFill>
+                  <a:srgbClr val="1F2A44"/>
+                </a:solidFill>
+              </a:defRPr>
+            </a:pPr>
+            <a:r>
+              <a:t>• Optuna TPE: proposes hyper-parameters where the good trials concentrate; report on held-out seeds</a:t>
+            </a:r>
+          </a:p>
+        </p:txBody>
+      </p:sp>
+    </p:spTree>
+  </p:cSld>
+  <p:clrMapOvr>
+    <a:masterClrMapping/>
+  </p:clrMapOvr>
+</p:sld>
+</file>
+
 <file path=ppt/slides/slide2.xml><?xml version="1.0" encoding="utf-8"?>
 <p:sld xmlns:a="http://schemas.openxmlformats.org/drawingml/2006/main" xmlns:p="http://schemas.openxmlformats.org/presentationml/2006/main" xmlns:r="http://schemas.openxmlformats.org/officeDocument/2006/relationships">
   <p:cSld>
@@ -3683,7 +3935,37 @@
               </a:defRPr>
             </a:pPr>
             <a:r>
-              <a:t>• Slippery: Q-learning reaches Q* more accurately; SARSA learns Q of the ε-greedy policy (lower values near the pit)</a:t>
+              <a:t>• Slippery, default schedule (ε_min = 0.05, constant α): Q-learning 19/20 seeds optimal, SARSA 15/20</a:t>
+            </a:r>
+          </a:p>
+          <a:p>
+            <a:pPr>
+              <a:spcAft>
+                <a:spcPts val="600"/>
+              </a:spcAft>
+              <a:defRPr sz="1600" b="0">
+                <a:solidFill>
+                  <a:srgbClr val="1F2A44"/>
+                </a:solidFill>
+              </a:defRPr>
+            </a:pPr>
+            <a:r>
+              <a:t>• SARSA learns Q of the ε-greedy policy and rarely visits the states next to the pit</a:t>
+            </a:r>
+          </a:p>
+          <a:p>
+            <a:pPr>
+              <a:spcAft>
+                <a:spcPts val="600"/>
+              </a:spcAft>
+              <a:defRPr sz="1600" b="0">
+                <a:solidFill>
+                  <a:srgbClr val="1F2A44"/>
+                </a:solidFill>
+              </a:defRPr>
+            </a:pPr>
+            <a:r>
+              <a:t>• Theory fix: GLIE (ε → 0) + Robbins–Monro α(s,a) = α/(1+k·N) → both 20/20 seeds optimal</a:t>
             </a:r>
           </a:p>
         </p:txBody>
@@ -4573,6 +4855,21 @@
               <a:t>• Over-fitting is visible: SARSA objective 0.001 on tuning seeds but 0.014 held-out</a:t>
             </a:r>
           </a:p>
+          <a:p>
+            <a:pPr>
+              <a:spcAft>
+                <a:spcPts val="600"/>
+              </a:spcAft>
+              <a:defRPr sz="1600" b="0">
+                <a:solidFill>
+                  <a:srgbClr val="1F2A44"/>
+                </a:solidFill>
+              </a:defRPr>
+            </a:pPr>
+            <a:r>
+              <a:t>• Lower regret ≠ more exact: tuned SARSA learns faster, but only 5/20 seeds reach exactly π*</a:t>
+            </a:r>
+          </a:p>
         </p:txBody>
       </p:sp>
       <p:pic>
@@ -4761,7 +5058,7 @@
               </a:defRPr>
             </a:pPr>
             <a:r>
-              <a:t>• Stochastic transitions need smaller/decaying α, more episodes and slower ε decay</a:t>
+              <a:t>• Stochastic transitions need decaying α and ε → 0 (Robbins–Monro + GLIE) to reach π* in every seed</a:t>
             </a:r>
           </a:p>
           <a:p>
@@ -4807,6 +5104,271 @@
             </a:pPr>
             <a:r>
               <a:t>• Everything is reproducible: results cached; `python -m experiments.run_all` redraws without training</a:t>
+            </a:r>
+          </a:p>
+        </p:txBody>
+      </p:sp>
+    </p:spTree>
+  </p:cSld>
+  <p:clrMapOvr>
+    <a:masterClrMapping/>
+  </p:clrMapOvr>
+</p:sld>
+</file>
+
+<file path=ppt/slides/slide9.xml><?xml version="1.0" encoding="utf-8"?>
+<p:sld xmlns:a="http://schemas.openxmlformats.org/drawingml/2006/main" xmlns:p="http://schemas.openxmlformats.org/presentationml/2006/main" xmlns:r="http://schemas.openxmlformats.org/officeDocument/2006/relationships">
+  <p:cSld>
+    <p:spTree>
+      <p:nvGrpSpPr>
+        <p:cNvPr id="1" name=""/>
+        <p:cNvGrpSpPr/>
+        <p:nvPr/>
+      </p:nvGrpSpPr>
+      <p:grpSpPr/>
+      <p:sp>
+        <p:nvSpPr>
+          <p:cNvPr id="2" name="Rectangle 1"/>
+          <p:cNvSpPr/>
+          <p:nvPr/>
+        </p:nvSpPr>
+        <p:spPr>
+          <a:xfrm>
+            <a:off x="0" y="0"/>
+            <a:ext cx="12191695" cy="109728"/>
+          </a:xfrm>
+          <a:prstGeom prst="rect">
+            <a:avLst/>
+          </a:prstGeom>
+          <a:solidFill>
+            <a:srgbClr val="D55E00"/>
+          </a:solidFill>
+          <a:ln>
+            <a:noFill/>
+          </a:ln>
+        </p:spPr>
+        <p:style>
+          <a:lnRef idx="1">
+            <a:schemeClr val="accent1"/>
+          </a:lnRef>
+          <a:fillRef idx="3">
+            <a:schemeClr val="accent1"/>
+          </a:fillRef>
+          <a:effectRef idx="2">
+            <a:schemeClr val="accent1"/>
+          </a:effectRef>
+          <a:fontRef idx="minor">
+            <a:schemeClr val="lt1"/>
+          </a:fontRef>
+        </p:style>
+        <p:txBody>
+          <a:bodyPr rtlCol="0" anchor="ctr"/>
+          <a:lstStyle/>
+          <a:p>
+            <a:pPr algn="ctr"/>
+          </a:p>
+        </p:txBody>
+      </p:sp>
+      <p:sp>
+        <p:nvSpPr>
+          <p:cNvPr id="3" name="TextBox 2"/>
+          <p:cNvSpPr txBox="1"/>
+          <p:nvPr/>
+        </p:nvSpPr>
+        <p:spPr>
+          <a:xfrm>
+            <a:off x="457200" y="228600"/>
+            <a:ext cx="11247120" cy="640080"/>
+          </a:xfrm>
+          <a:prstGeom prst="rect">
+            <a:avLst/>
+          </a:prstGeom>
+          <a:noFill/>
+        </p:spPr>
+        <p:txBody>
+          <a:bodyPr wrap="square">
+            <a:spAutoFit/>
+          </a:bodyPr>
+          <a:lstStyle/>
+          <a:p>
+            <a:pPr>
+              <a:spcAft>
+                <a:spcPts val="600"/>
+              </a:spcAft>
+              <a:defRPr sz="2800" b="1">
+                <a:solidFill>
+                  <a:srgbClr val="1F2A44"/>
+                </a:solidFill>
+              </a:defRPr>
+            </a:pPr>
+            <a:r>
+              <a:t>Backup: dynamic programming (model-based)</a:t>
+            </a:r>
+          </a:p>
+        </p:txBody>
+      </p:sp>
+      <p:sp>
+        <p:nvSpPr>
+          <p:cNvPr id="4" name="TextBox 3"/>
+          <p:cNvSpPr txBox="1"/>
+          <p:nvPr/>
+        </p:nvSpPr>
+        <p:spPr>
+          <a:xfrm>
+            <a:off x="457200" y="822960"/>
+            <a:ext cx="11247120" cy="457200"/>
+          </a:xfrm>
+          <a:prstGeom prst="rect">
+            <a:avLst/>
+          </a:prstGeom>
+          <a:noFill/>
+        </p:spPr>
+        <p:txBody>
+          <a:bodyPr wrap="square">
+            <a:spAutoFit/>
+          </a:bodyPr>
+          <a:lstStyle/>
+          <a:p>
+            <a:pPr>
+              <a:spcAft>
+                <a:spcPts val="600"/>
+              </a:spcAft>
+              <a:defRPr sz="1500" b="0">
+                <a:solidFill>
+                  <a:srgbClr val="555B66"/>
+                </a:solidFill>
+              </a:defRPr>
+            </a:pPr>
+            <a:r>
+              <a:t>Used only as ground truth; agents never see P</a:t>
+            </a:r>
+          </a:p>
+        </p:txBody>
+      </p:sp>
+      <p:sp>
+        <p:nvSpPr>
+          <p:cNvPr id="5" name="TextBox 4"/>
+          <p:cNvSpPr txBox="1"/>
+          <p:nvPr/>
+        </p:nvSpPr>
+        <p:spPr>
+          <a:xfrm>
+            <a:off x="640080" y="1371600"/>
+            <a:ext cx="10972800" cy="5029200"/>
+          </a:xfrm>
+          <a:prstGeom prst="rect">
+            <a:avLst/>
+          </a:prstGeom>
+          <a:noFill/>
+        </p:spPr>
+        <p:txBody>
+          <a:bodyPr wrap="square">
+            <a:spAutoFit/>
+          </a:bodyPr>
+          <a:lstStyle/>
+          <a:p>
+            <a:pPr>
+              <a:spcAft>
+                <a:spcPts val="600"/>
+              </a:spcAft>
+              <a:defRPr sz="2000" b="0">
+                <a:solidFill>
+                  <a:srgbClr val="1F2A44"/>
+                </a:solidFill>
+              </a:defRPr>
+            </a:pPr>
+            <a:r>
+              <a:t>• Value iteration: apply the BOE  V(s) ← max_a Σ p(s'|s,a)[r + γV(s')]  until Δ &lt; θ</a:t>
+            </a:r>
+          </a:p>
+          <a:p>
+            <a:pPr>
+              <a:spcAft>
+                <a:spcPts val="600"/>
+              </a:spcAft>
+              <a:defRPr sz="2000" b="0">
+                <a:solidFill>
+                  <a:srgbClr val="1F2A44"/>
+                </a:solidFill>
+              </a:defRPr>
+            </a:pPr>
+            <a:r>
+              <a:t>• Policy iteration: evaluate π exactly (Bellman eq. → linear system), then improve greedily</a:t>
+            </a:r>
+          </a:p>
+          <a:p>
+            <a:pPr>
+              <a:spcAft>
+                <a:spcPts val="600"/>
+              </a:spcAft>
+              <a:defRPr sz="2000" b="0">
+                <a:solidFill>
+                  <a:srgbClr val="1F2A44"/>
+                </a:solidFill>
+              </a:defRPr>
+            </a:pPr>
+            <a:r>
+              <a:t>• Both give the same V* (unit test). Number of sweeps:</a:t>
+            </a:r>
+          </a:p>
+          <a:p>
+            <a:pPr>
+              <a:spcAft>
+                <a:spcPts val="600"/>
+              </a:spcAft>
+              <a:defRPr sz="2000" b="0">
+                <a:solidFill>
+                  <a:srgbClr val="1F2A44"/>
+                </a:solidFill>
+              </a:defRPr>
+            </a:pPr>
+            <a:r>
+              <a:t>      Deterministic grid:  VI 6   ·  PI 6</a:t>
+            </a:r>
+          </a:p>
+          <a:p>
+            <a:pPr>
+              <a:spcAft>
+                <a:spcPts val="600"/>
+              </a:spcAft>
+              <a:defRPr sz="2000" b="0">
+                <a:solidFill>
+                  <a:srgbClr val="1F2A44"/>
+                </a:solidFill>
+              </a:defRPr>
+            </a:pPr>
+            <a:r>
+              <a:t>      Slippery grid:        VI 145  ·  PI 7</a:t>
+            </a:r>
+          </a:p>
+          <a:p>
+            <a:pPr>
+              <a:spcAft>
+                <a:spcPts val="600"/>
+              </a:spcAft>
+              <a:defRPr sz="2000" b="0">
+                <a:solidFill>
+                  <a:srgbClr val="1F2A44"/>
+                </a:solidFill>
+              </a:defRPr>
+            </a:pPr>
+            <a:r>
+              <a:t>      Cliff Walking:         VI 15  ·  PI 15</a:t>
+            </a:r>
+          </a:p>
+          <a:p>
+            <a:pPr>
+              <a:spcAft>
+                <a:spcPts val="600"/>
+              </a:spcAft>
+              <a:defRPr sz="2000" b="0">
+                <a:solidFill>
+                  <a:srgbClr val="1F2A44"/>
+                </a:solidFill>
+              </a:defRPr>
+            </a:pPr>
+            <a:r>
+              <a:t>• VI: cheap sweeps, asymptotic convergence · PI: expensive steps, exact in a few iterations</a:t>
             </a:r>
           </a:p>
         </p:txBody>

</xml_diff>

<commit_message>
Failure analysis in Cliff Walking, MC constant-alpha and exploring starts, convergent-schedule figure
- exp6: explains why Monte Carlo (1/N) and Double Q (alpha 0.5) get stuck at the
  -1/(1-gamma) = -100 plateau, and shows the fixes (constant-alpha MC, exploring
  starts, smaller alpha)
- Monte Carlo: optional constant step size and exploring starts (class MC-ES)
- Robbins-Monro alpha_decay also for Double Q-learning and n-step SARSA
- exp1: figure comparing the default schedule with GLIE + decaying alpha
- README, THEORY and slides updated
</commit_message>
<xml_diff>
--- a/docs/presentation.pptx
+++ b/docs/presentation.pptx
@@ -15,6 +15,7 @@
     <p:sldId id="263" r:id="rId14"/>
     <p:sldId id="264" r:id="rId15"/>
     <p:sldId id="265" r:id="rId16"/>
+    <p:sldId id="266" r:id="rId17"/>
   </p:sldIdLst>
   <p:sldSz cx="12191695" cy="6858000" type="screen4x3"/>
   <p:notesSz cx="6858000" cy="9144000"/>
@@ -3305,6 +3306,271 @@
               </a:defRPr>
             </a:pPr>
             <a:r>
+              <a:t>Backup: dynamic programming (model-based)</a:t>
+            </a:r>
+          </a:p>
+        </p:txBody>
+      </p:sp>
+      <p:sp>
+        <p:nvSpPr>
+          <p:cNvPr id="4" name="TextBox 3"/>
+          <p:cNvSpPr txBox="1"/>
+          <p:nvPr/>
+        </p:nvSpPr>
+        <p:spPr>
+          <a:xfrm>
+            <a:off x="457200" y="822960"/>
+            <a:ext cx="11247120" cy="457200"/>
+          </a:xfrm>
+          <a:prstGeom prst="rect">
+            <a:avLst/>
+          </a:prstGeom>
+          <a:noFill/>
+        </p:spPr>
+        <p:txBody>
+          <a:bodyPr wrap="square">
+            <a:spAutoFit/>
+          </a:bodyPr>
+          <a:lstStyle/>
+          <a:p>
+            <a:pPr>
+              <a:spcAft>
+                <a:spcPts val="600"/>
+              </a:spcAft>
+              <a:defRPr sz="1500" b="0">
+                <a:solidFill>
+                  <a:srgbClr val="555B66"/>
+                </a:solidFill>
+              </a:defRPr>
+            </a:pPr>
+            <a:r>
+              <a:t>Used only as ground truth; agents never see P</a:t>
+            </a:r>
+          </a:p>
+        </p:txBody>
+      </p:sp>
+      <p:sp>
+        <p:nvSpPr>
+          <p:cNvPr id="5" name="TextBox 4"/>
+          <p:cNvSpPr txBox="1"/>
+          <p:nvPr/>
+        </p:nvSpPr>
+        <p:spPr>
+          <a:xfrm>
+            <a:off x="640080" y="1371600"/>
+            <a:ext cx="10972800" cy="5029200"/>
+          </a:xfrm>
+          <a:prstGeom prst="rect">
+            <a:avLst/>
+          </a:prstGeom>
+          <a:noFill/>
+        </p:spPr>
+        <p:txBody>
+          <a:bodyPr wrap="square">
+            <a:spAutoFit/>
+          </a:bodyPr>
+          <a:lstStyle/>
+          <a:p>
+            <a:pPr>
+              <a:spcAft>
+                <a:spcPts val="600"/>
+              </a:spcAft>
+              <a:defRPr sz="2000" b="0">
+                <a:solidFill>
+                  <a:srgbClr val="1F2A44"/>
+                </a:solidFill>
+              </a:defRPr>
+            </a:pPr>
+            <a:r>
+              <a:t>• Value iteration: apply the BOE  V(s) ← max_a Σ p(s'|s,a)[r + γV(s')]  until Δ &lt; θ</a:t>
+            </a:r>
+          </a:p>
+          <a:p>
+            <a:pPr>
+              <a:spcAft>
+                <a:spcPts val="600"/>
+              </a:spcAft>
+              <a:defRPr sz="2000" b="0">
+                <a:solidFill>
+                  <a:srgbClr val="1F2A44"/>
+                </a:solidFill>
+              </a:defRPr>
+            </a:pPr>
+            <a:r>
+              <a:t>• Policy iteration: evaluate π exactly (Bellman eq. → linear system), then improve greedily</a:t>
+            </a:r>
+          </a:p>
+          <a:p>
+            <a:pPr>
+              <a:spcAft>
+                <a:spcPts val="600"/>
+              </a:spcAft>
+              <a:defRPr sz="2000" b="0">
+                <a:solidFill>
+                  <a:srgbClr val="1F2A44"/>
+                </a:solidFill>
+              </a:defRPr>
+            </a:pPr>
+            <a:r>
+              <a:t>• Both give the same V* (unit test). Number of sweeps:</a:t>
+            </a:r>
+          </a:p>
+          <a:p>
+            <a:pPr>
+              <a:spcAft>
+                <a:spcPts val="600"/>
+              </a:spcAft>
+              <a:defRPr sz="2000" b="0">
+                <a:solidFill>
+                  <a:srgbClr val="1F2A44"/>
+                </a:solidFill>
+              </a:defRPr>
+            </a:pPr>
+            <a:r>
+              <a:t>      Deterministic grid:  VI 6   ·  PI 6</a:t>
+            </a:r>
+          </a:p>
+          <a:p>
+            <a:pPr>
+              <a:spcAft>
+                <a:spcPts val="600"/>
+              </a:spcAft>
+              <a:defRPr sz="2000" b="0">
+                <a:solidFill>
+                  <a:srgbClr val="1F2A44"/>
+                </a:solidFill>
+              </a:defRPr>
+            </a:pPr>
+            <a:r>
+              <a:t>      Slippery grid:        VI 145  ·  PI 7</a:t>
+            </a:r>
+          </a:p>
+          <a:p>
+            <a:pPr>
+              <a:spcAft>
+                <a:spcPts val="600"/>
+              </a:spcAft>
+              <a:defRPr sz="2000" b="0">
+                <a:solidFill>
+                  <a:srgbClr val="1F2A44"/>
+                </a:solidFill>
+              </a:defRPr>
+            </a:pPr>
+            <a:r>
+              <a:t>      Cliff Walking:         VI 15  ·  PI 15</a:t>
+            </a:r>
+          </a:p>
+          <a:p>
+            <a:pPr>
+              <a:spcAft>
+                <a:spcPts val="600"/>
+              </a:spcAft>
+              <a:defRPr sz="2000" b="0">
+                <a:solidFill>
+                  <a:srgbClr val="1F2A44"/>
+                </a:solidFill>
+              </a:defRPr>
+            </a:pPr>
+            <a:r>
+              <a:t>• VI: cheap sweeps, asymptotic convergence · PI: expensive steps, exact in a few iterations</a:t>
+            </a:r>
+          </a:p>
+        </p:txBody>
+      </p:sp>
+    </p:spTree>
+  </p:cSld>
+  <p:clrMapOvr>
+    <a:masterClrMapping/>
+  </p:clrMapOvr>
+</p:sld>
+</file>
+
+<file path=ppt/slides/slide11.xml><?xml version="1.0" encoding="utf-8"?>
+<p:sld xmlns:a="http://schemas.openxmlformats.org/drawingml/2006/main" xmlns:p="http://schemas.openxmlformats.org/presentationml/2006/main" xmlns:r="http://schemas.openxmlformats.org/officeDocument/2006/relationships">
+  <p:cSld>
+    <p:spTree>
+      <p:nvGrpSpPr>
+        <p:cNvPr id="1" name=""/>
+        <p:cNvGrpSpPr/>
+        <p:nvPr/>
+      </p:nvGrpSpPr>
+      <p:grpSpPr/>
+      <p:sp>
+        <p:nvSpPr>
+          <p:cNvPr id="2" name="Rectangle 1"/>
+          <p:cNvSpPr/>
+          <p:nvPr/>
+        </p:nvSpPr>
+        <p:spPr>
+          <a:xfrm>
+            <a:off x="0" y="0"/>
+            <a:ext cx="12191695" cy="109728"/>
+          </a:xfrm>
+          <a:prstGeom prst="rect">
+            <a:avLst/>
+          </a:prstGeom>
+          <a:solidFill>
+            <a:srgbClr val="D55E00"/>
+          </a:solidFill>
+          <a:ln>
+            <a:noFill/>
+          </a:ln>
+        </p:spPr>
+        <p:style>
+          <a:lnRef idx="1">
+            <a:schemeClr val="accent1"/>
+          </a:lnRef>
+          <a:fillRef idx="3">
+            <a:schemeClr val="accent1"/>
+          </a:fillRef>
+          <a:effectRef idx="2">
+            <a:schemeClr val="accent1"/>
+          </a:effectRef>
+          <a:fontRef idx="minor">
+            <a:schemeClr val="lt1"/>
+          </a:fontRef>
+        </p:style>
+        <p:txBody>
+          <a:bodyPr rtlCol="0" anchor="ctr"/>
+          <a:lstStyle/>
+          <a:p>
+            <a:pPr algn="ctr"/>
+          </a:p>
+        </p:txBody>
+      </p:sp>
+      <p:sp>
+        <p:nvSpPr>
+          <p:cNvPr id="3" name="TextBox 2"/>
+          <p:cNvSpPr txBox="1"/>
+          <p:nvPr/>
+        </p:nvSpPr>
+        <p:spPr>
+          <a:xfrm>
+            <a:off x="457200" y="228600"/>
+            <a:ext cx="11247120" cy="640080"/>
+          </a:xfrm>
+          <a:prstGeom prst="rect">
+            <a:avLst/>
+          </a:prstGeom>
+          <a:noFill/>
+        </p:spPr>
+        <p:txBody>
+          <a:bodyPr wrap="square">
+            <a:spAutoFit/>
+          </a:bodyPr>
+          <a:lstStyle/>
+          <a:p>
+            <a:pPr>
+              <a:spcAft>
+                <a:spcPts val="600"/>
+              </a:spcAft>
+              <a:defRPr sz="2800" b="1">
+                <a:solidFill>
+                  <a:srgbClr val="1F2A44"/>
+                </a:solidFill>
+              </a:defRPr>
+            </a:pPr>
+            <a:r>
               <a:t>Backup: extras beyond the class slides</a:t>
             </a:r>
           </a:p>
@@ -5202,7 +5468,7 @@
               </a:defRPr>
             </a:pPr>
             <a:r>
-              <a:t>Backup: dynamic programming (model-based)</a:t>
+              <a:t>Backup: why MC and Double Q fail in Cliff Walking</a:t>
             </a:r>
           </a:p>
         </p:txBody>
@@ -5240,7 +5506,7 @@
               </a:defRPr>
             </a:pPr>
             <a:r>
-              <a:t>Used only as ground truth; agents never see P</a:t>
+              <a:t>Estimates collapse to the −1/(1−γ) = −100 'never arrive' plateau</a:t>
             </a:r>
           </a:p>
         </p:txBody>
@@ -5253,8 +5519,8 @@
         </p:nvSpPr>
         <p:spPr>
           <a:xfrm>
-            <a:off x="640080" y="1371600"/>
-            <a:ext cx="10972800" cy="5029200"/>
+            <a:off x="457200" y="1463040"/>
+            <a:ext cx="3657508" cy="5029200"/>
           </a:xfrm>
           <a:prstGeom prst="rect">
             <a:avLst/>
@@ -5271,108 +5537,72 @@
               <a:spcAft>
                 <a:spcPts val="600"/>
               </a:spcAft>
-              <a:defRPr sz="2000" b="0">
+              <a:defRPr sz="1600" b="0">
                 <a:solidFill>
                   <a:srgbClr val="1F2A44"/>
                 </a:solidFill>
               </a:defRPr>
             </a:pPr>
             <a:r>
-              <a:t>• Value iteration: apply the BOE  V(s) ← max_a Σ p(s'|s,a)[r + γV(s')]  until Δ &lt; θ</a:t>
-            </a:r>
-          </a:p>
-          <a:p>
-            <a:pPr>
-              <a:spcAft>
-                <a:spcPts val="600"/>
-              </a:spcAft>
-              <a:defRPr sz="2000" b="0">
+              <a:t>• MC with 1/N: the −1500 returns of the first episodes stay in the mean forever (non-stationary target)</a:t>
+            </a:r>
+          </a:p>
+          <a:p>
+            <a:pPr>
+              <a:spcAft>
+                <a:spcPts val="600"/>
+              </a:spcAft>
+              <a:defRPr sz="1600" b="0">
                 <a:solidFill>
                   <a:srgbClr val="1F2A44"/>
                 </a:solidFill>
               </a:defRPr>
             </a:pPr>
             <a:r>
-              <a:t>• Policy iteration: evaluate π exactly (Bellman eq. → linear system), then improve greedily</a:t>
-            </a:r>
-          </a:p>
-          <a:p>
-            <a:pPr>
-              <a:spcAft>
-                <a:spcPts val="600"/>
-              </a:spcAft>
-              <a:defRPr sz="2000" b="0">
+              <a:t>• Constant-α MC: 14/20 stuck seeds → 0/20; exploring starts helps further</a:t>
+            </a:r>
+          </a:p>
+          <a:p>
+            <a:pPr>
+              <a:spcAft>
+                <a:spcPts val="600"/>
+              </a:spcAft>
+              <a:defRPr sz="1600" b="0">
                 <a:solidFill>
                   <a:srgbClr val="1F2A44"/>
                 </a:solidFill>
               </a:defRPr>
             </a:pPr>
             <a:r>
-              <a:t>• Both give the same V* (unit test). Number of sweeps:</a:t>
-            </a:r>
-          </a:p>
-          <a:p>
-            <a:pPr>
-              <a:spcAft>
-                <a:spcPts val="600"/>
-              </a:spcAft>
-              <a:defRPr sz="2000" b="0">
-                <a:solidFill>
-                  <a:srgbClr val="1F2A44"/>
-                </a:solidFill>
-              </a:defRPr>
-            </a:pPr>
-            <a:r>
-              <a:t>      Deterministic grid:  VI 6   ·  PI 6</a:t>
-            </a:r>
-          </a:p>
-          <a:p>
-            <a:pPr>
-              <a:spcAft>
-                <a:spcPts val="600"/>
-              </a:spcAft>
-              <a:defRPr sz="2000" b="0">
-                <a:solidFill>
-                  <a:srgbClr val="1F2A44"/>
-                </a:solidFill>
-              </a:defRPr>
-            </a:pPr>
-            <a:r>
-              <a:t>      Slippery grid:        VI 145  ·  PI 7</a:t>
-            </a:r>
-          </a:p>
-          <a:p>
-            <a:pPr>
-              <a:spcAft>
-                <a:spcPts val="600"/>
-              </a:spcAft>
-              <a:defRPr sz="2000" b="0">
-                <a:solidFill>
-                  <a:srgbClr val="1F2A44"/>
-                </a:solidFill>
-              </a:defRPr>
-            </a:pPr>
-            <a:r>
-              <a:t>      Cliff Walking:         VI 15  ·  PI 15</a:t>
-            </a:r>
-          </a:p>
-          <a:p>
-            <a:pPr>
-              <a:spcAft>
-                <a:spcPts val="600"/>
-              </a:spcAft>
-              <a:defRPr sz="2000" b="0">
-                <a:solidFill>
-                  <a:srgbClr val="1F2A44"/>
-                </a:solidFill>
-              </a:defRPr>
-            </a:pPr>
-            <a:r>
-              <a:t>• VI: cheap sweeps, asymptotic convergence · PI: expensive steps, exact in a few iterations</a:t>
-            </a:r>
-          </a:p>
-        </p:txBody>
-      </p:sp>
+              <a:t>• Double Q, α = 0.5: 3/20 seeds collapse to −100; α = 0.1 → 0/20</a:t>
+            </a:r>
+          </a:p>
+        </p:txBody>
+      </p:sp>
+      <p:pic>
+        <p:nvPicPr>
+          <p:cNvPr id="6" name="Picture 5" descr="exp6_failure_analysis.png"/>
+          <p:cNvPicPr>
+            <a:picLocks noChangeAspect="1"/>
+          </p:cNvPicPr>
+          <p:nvPr/>
+        </p:nvPicPr>
+        <p:blipFill>
+          <a:blip r:embed="rId2"/>
+          <a:stretch>
+            <a:fillRect/>
+          </a:stretch>
+        </p:blipFill>
+        <p:spPr>
+          <a:xfrm>
+            <a:off x="4206148" y="1371600"/>
+            <a:ext cx="7619786" cy="2543639"/>
+          </a:xfrm>
+          <a:prstGeom prst="rect">
+            <a:avLst/>
+          </a:prstGeom>
+        </p:spPr>
+      </p:pic>
     </p:spTree>
   </p:cSld>
   <p:clrMapOvr>

</xml_diff>

<commit_message>
Optuna study results: 12 multi-objective studies x 150 trials (trained on Windows)
- results/optuna/studies.db and the held-out evaluation cache
- exp4 figures and tables: tuned vs default on 20 held-out seeds, Pareto fronts,
  parameter importance
- README, THEORY and slides: findings of the full study
</commit_message>
<xml_diff>
--- a/docs/presentation.pptx
+++ b/docs/presentation.pptx
@@ -16,6 +16,7 @@
     <p:sldId id="264" r:id="rId15"/>
     <p:sldId id="265" r:id="rId16"/>
     <p:sldId id="266" r:id="rId17"/>
+    <p:sldId id="267" r:id="rId18"/>
   </p:sldIdLst>
   <p:sldSz cx="12191695" cy="6858000" type="screen4x3"/>
   <p:notesSz cx="6858000" cy="9144000"/>
@@ -3306,7 +3307,7 @@
               </a:defRPr>
             </a:pPr>
             <a:r>
-              <a:t>Backup: dynamic programming (model-based)</a:t>
+              <a:t>Backup: why MC and Double Q fail in Cliff Walking</a:t>
             </a:r>
           </a:p>
         </p:txBody>
@@ -3344,7 +3345,7 @@
               </a:defRPr>
             </a:pPr>
             <a:r>
-              <a:t>Used only as ground truth; agents never see P</a:t>
+              <a:t>Estimates collapse to the −1/(1−γ) = −100 'never arrive' plateau</a:t>
             </a:r>
           </a:p>
         </p:txBody>
@@ -3357,8 +3358,8 @@
         </p:nvSpPr>
         <p:spPr>
           <a:xfrm>
-            <a:off x="640080" y="1371600"/>
-            <a:ext cx="10972800" cy="5029200"/>
+            <a:off x="457200" y="1463040"/>
+            <a:ext cx="3657508" cy="5029200"/>
           </a:xfrm>
           <a:prstGeom prst="rect">
             <a:avLst/>
@@ -3375,108 +3376,72 @@
               <a:spcAft>
                 <a:spcPts val="600"/>
               </a:spcAft>
-              <a:defRPr sz="2000" b="0">
+              <a:defRPr sz="1600" b="0">
                 <a:solidFill>
                   <a:srgbClr val="1F2A44"/>
                 </a:solidFill>
               </a:defRPr>
             </a:pPr>
             <a:r>
-              <a:t>• Value iteration: apply the BOE  V(s) ← max_a Σ p(s'|s,a)[r + γV(s')]  until Δ &lt; θ</a:t>
-            </a:r>
-          </a:p>
-          <a:p>
-            <a:pPr>
-              <a:spcAft>
-                <a:spcPts val="600"/>
-              </a:spcAft>
-              <a:defRPr sz="2000" b="0">
+              <a:t>• MC with 1/N: the −1500 returns of the first episodes stay in the mean forever (non-stationary target)</a:t>
+            </a:r>
+          </a:p>
+          <a:p>
+            <a:pPr>
+              <a:spcAft>
+                <a:spcPts val="600"/>
+              </a:spcAft>
+              <a:defRPr sz="1600" b="0">
                 <a:solidFill>
                   <a:srgbClr val="1F2A44"/>
                 </a:solidFill>
               </a:defRPr>
             </a:pPr>
             <a:r>
-              <a:t>• Policy iteration: evaluate π exactly (Bellman eq. → linear system), then improve greedily</a:t>
-            </a:r>
-          </a:p>
-          <a:p>
-            <a:pPr>
-              <a:spcAft>
-                <a:spcPts val="600"/>
-              </a:spcAft>
-              <a:defRPr sz="2000" b="0">
+              <a:t>• Constant-α MC: 14/20 stuck seeds → 0/20; exploring starts helps further</a:t>
+            </a:r>
+          </a:p>
+          <a:p>
+            <a:pPr>
+              <a:spcAft>
+                <a:spcPts val="600"/>
+              </a:spcAft>
+              <a:defRPr sz="1600" b="0">
                 <a:solidFill>
                   <a:srgbClr val="1F2A44"/>
                 </a:solidFill>
               </a:defRPr>
             </a:pPr>
             <a:r>
-              <a:t>• Both give the same V* (unit test). Number of sweeps:</a:t>
-            </a:r>
-          </a:p>
-          <a:p>
-            <a:pPr>
-              <a:spcAft>
-                <a:spcPts val="600"/>
-              </a:spcAft>
-              <a:defRPr sz="2000" b="0">
-                <a:solidFill>
-                  <a:srgbClr val="1F2A44"/>
-                </a:solidFill>
-              </a:defRPr>
-            </a:pPr>
-            <a:r>
-              <a:t>      Deterministic grid:  VI 6   ·  PI 6</a:t>
-            </a:r>
-          </a:p>
-          <a:p>
-            <a:pPr>
-              <a:spcAft>
-                <a:spcPts val="600"/>
-              </a:spcAft>
-              <a:defRPr sz="2000" b="0">
-                <a:solidFill>
-                  <a:srgbClr val="1F2A44"/>
-                </a:solidFill>
-              </a:defRPr>
-            </a:pPr>
-            <a:r>
-              <a:t>      Slippery grid:        VI 145  ·  PI 7</a:t>
-            </a:r>
-          </a:p>
-          <a:p>
-            <a:pPr>
-              <a:spcAft>
-                <a:spcPts val="600"/>
-              </a:spcAft>
-              <a:defRPr sz="2000" b="0">
-                <a:solidFill>
-                  <a:srgbClr val="1F2A44"/>
-                </a:solidFill>
-              </a:defRPr>
-            </a:pPr>
-            <a:r>
-              <a:t>      Cliff Walking:         VI 15  ·  PI 15</a:t>
-            </a:r>
-          </a:p>
-          <a:p>
-            <a:pPr>
-              <a:spcAft>
-                <a:spcPts val="600"/>
-              </a:spcAft>
-              <a:defRPr sz="2000" b="0">
-                <a:solidFill>
-                  <a:srgbClr val="1F2A44"/>
-                </a:solidFill>
-              </a:defRPr>
-            </a:pPr>
-            <a:r>
-              <a:t>• VI: cheap sweeps, asymptotic convergence · PI: expensive steps, exact in a few iterations</a:t>
-            </a:r>
-          </a:p>
-        </p:txBody>
-      </p:sp>
+              <a:t>• Double Q, α = 0.5: 3/20 seeds collapse to −100; α = 0.1 → 0/20</a:t>
+            </a:r>
+          </a:p>
+        </p:txBody>
+      </p:sp>
+      <p:pic>
+        <p:nvPicPr>
+          <p:cNvPr id="6" name="Picture 5" descr="exp6_failure_analysis.png"/>
+          <p:cNvPicPr>
+            <a:picLocks noChangeAspect="1"/>
+          </p:cNvPicPr>
+          <p:nvPr/>
+        </p:nvPicPr>
+        <p:blipFill>
+          <a:blip r:embed="rId2"/>
+          <a:stretch>
+            <a:fillRect/>
+          </a:stretch>
+        </p:blipFill>
+        <p:spPr>
+          <a:xfrm>
+            <a:off x="4206148" y="1371600"/>
+            <a:ext cx="7619786" cy="2543639"/>
+          </a:xfrm>
+          <a:prstGeom prst="rect">
+            <a:avLst/>
+          </a:prstGeom>
+        </p:spPr>
+      </p:pic>
     </p:spTree>
   </p:cSld>
   <p:clrMapOvr>
@@ -3486,6 +3451,271 @@
 </file>
 
 <file path=ppt/slides/slide11.xml><?xml version="1.0" encoding="utf-8"?>
+<p:sld xmlns:a="http://schemas.openxmlformats.org/drawingml/2006/main" xmlns:p="http://schemas.openxmlformats.org/presentationml/2006/main" xmlns:r="http://schemas.openxmlformats.org/officeDocument/2006/relationships">
+  <p:cSld>
+    <p:spTree>
+      <p:nvGrpSpPr>
+        <p:cNvPr id="1" name=""/>
+        <p:cNvGrpSpPr/>
+        <p:nvPr/>
+      </p:nvGrpSpPr>
+      <p:grpSpPr/>
+      <p:sp>
+        <p:nvSpPr>
+          <p:cNvPr id="2" name="Rectangle 1"/>
+          <p:cNvSpPr/>
+          <p:nvPr/>
+        </p:nvSpPr>
+        <p:spPr>
+          <a:xfrm>
+            <a:off x="0" y="0"/>
+            <a:ext cx="12191695" cy="109728"/>
+          </a:xfrm>
+          <a:prstGeom prst="rect">
+            <a:avLst/>
+          </a:prstGeom>
+          <a:solidFill>
+            <a:srgbClr val="D55E00"/>
+          </a:solidFill>
+          <a:ln>
+            <a:noFill/>
+          </a:ln>
+        </p:spPr>
+        <p:style>
+          <a:lnRef idx="1">
+            <a:schemeClr val="accent1"/>
+          </a:lnRef>
+          <a:fillRef idx="3">
+            <a:schemeClr val="accent1"/>
+          </a:fillRef>
+          <a:effectRef idx="2">
+            <a:schemeClr val="accent1"/>
+          </a:effectRef>
+          <a:fontRef idx="minor">
+            <a:schemeClr val="lt1"/>
+          </a:fontRef>
+        </p:style>
+        <p:txBody>
+          <a:bodyPr rtlCol="0" anchor="ctr"/>
+          <a:lstStyle/>
+          <a:p>
+            <a:pPr algn="ctr"/>
+          </a:p>
+        </p:txBody>
+      </p:sp>
+      <p:sp>
+        <p:nvSpPr>
+          <p:cNvPr id="3" name="TextBox 2"/>
+          <p:cNvSpPr txBox="1"/>
+          <p:nvPr/>
+        </p:nvSpPr>
+        <p:spPr>
+          <a:xfrm>
+            <a:off x="457200" y="228600"/>
+            <a:ext cx="11247120" cy="640080"/>
+          </a:xfrm>
+          <a:prstGeom prst="rect">
+            <a:avLst/>
+          </a:prstGeom>
+          <a:noFill/>
+        </p:spPr>
+        <p:txBody>
+          <a:bodyPr wrap="square">
+            <a:spAutoFit/>
+          </a:bodyPr>
+          <a:lstStyle/>
+          <a:p>
+            <a:pPr>
+              <a:spcAft>
+                <a:spcPts val="600"/>
+              </a:spcAft>
+              <a:defRPr sz="2800" b="1">
+                <a:solidFill>
+                  <a:srgbClr val="1F2A44"/>
+                </a:solidFill>
+              </a:defRPr>
+            </a:pPr>
+            <a:r>
+              <a:t>Backup: dynamic programming (model-based)</a:t>
+            </a:r>
+          </a:p>
+        </p:txBody>
+      </p:sp>
+      <p:sp>
+        <p:nvSpPr>
+          <p:cNvPr id="4" name="TextBox 3"/>
+          <p:cNvSpPr txBox="1"/>
+          <p:nvPr/>
+        </p:nvSpPr>
+        <p:spPr>
+          <a:xfrm>
+            <a:off x="457200" y="822960"/>
+            <a:ext cx="11247120" cy="457200"/>
+          </a:xfrm>
+          <a:prstGeom prst="rect">
+            <a:avLst/>
+          </a:prstGeom>
+          <a:noFill/>
+        </p:spPr>
+        <p:txBody>
+          <a:bodyPr wrap="square">
+            <a:spAutoFit/>
+          </a:bodyPr>
+          <a:lstStyle/>
+          <a:p>
+            <a:pPr>
+              <a:spcAft>
+                <a:spcPts val="600"/>
+              </a:spcAft>
+              <a:defRPr sz="1500" b="0">
+                <a:solidFill>
+                  <a:srgbClr val="555B66"/>
+                </a:solidFill>
+              </a:defRPr>
+            </a:pPr>
+            <a:r>
+              <a:t>Used only as ground truth; agents never see P</a:t>
+            </a:r>
+          </a:p>
+        </p:txBody>
+      </p:sp>
+      <p:sp>
+        <p:nvSpPr>
+          <p:cNvPr id="5" name="TextBox 4"/>
+          <p:cNvSpPr txBox="1"/>
+          <p:nvPr/>
+        </p:nvSpPr>
+        <p:spPr>
+          <a:xfrm>
+            <a:off x="640080" y="1371600"/>
+            <a:ext cx="10972800" cy="5029200"/>
+          </a:xfrm>
+          <a:prstGeom prst="rect">
+            <a:avLst/>
+          </a:prstGeom>
+          <a:noFill/>
+        </p:spPr>
+        <p:txBody>
+          <a:bodyPr wrap="square">
+            <a:spAutoFit/>
+          </a:bodyPr>
+          <a:lstStyle/>
+          <a:p>
+            <a:pPr>
+              <a:spcAft>
+                <a:spcPts val="600"/>
+              </a:spcAft>
+              <a:defRPr sz="2000" b="0">
+                <a:solidFill>
+                  <a:srgbClr val="1F2A44"/>
+                </a:solidFill>
+              </a:defRPr>
+            </a:pPr>
+            <a:r>
+              <a:t>• Value iteration: apply the BOE  V(s) ← max_a Σ p(s'|s,a)[r + γV(s')]  until Δ &lt; θ</a:t>
+            </a:r>
+          </a:p>
+          <a:p>
+            <a:pPr>
+              <a:spcAft>
+                <a:spcPts val="600"/>
+              </a:spcAft>
+              <a:defRPr sz="2000" b="0">
+                <a:solidFill>
+                  <a:srgbClr val="1F2A44"/>
+                </a:solidFill>
+              </a:defRPr>
+            </a:pPr>
+            <a:r>
+              <a:t>• Policy iteration: evaluate π exactly (Bellman eq. → linear system), then improve greedily</a:t>
+            </a:r>
+          </a:p>
+          <a:p>
+            <a:pPr>
+              <a:spcAft>
+                <a:spcPts val="600"/>
+              </a:spcAft>
+              <a:defRPr sz="2000" b="0">
+                <a:solidFill>
+                  <a:srgbClr val="1F2A44"/>
+                </a:solidFill>
+              </a:defRPr>
+            </a:pPr>
+            <a:r>
+              <a:t>• Both give the same V* (unit test). Number of sweeps:</a:t>
+            </a:r>
+          </a:p>
+          <a:p>
+            <a:pPr>
+              <a:spcAft>
+                <a:spcPts val="600"/>
+              </a:spcAft>
+              <a:defRPr sz="2000" b="0">
+                <a:solidFill>
+                  <a:srgbClr val="1F2A44"/>
+                </a:solidFill>
+              </a:defRPr>
+            </a:pPr>
+            <a:r>
+              <a:t>      Deterministic grid:  VI 6   ·  PI 6</a:t>
+            </a:r>
+          </a:p>
+          <a:p>
+            <a:pPr>
+              <a:spcAft>
+                <a:spcPts val="600"/>
+              </a:spcAft>
+              <a:defRPr sz="2000" b="0">
+                <a:solidFill>
+                  <a:srgbClr val="1F2A44"/>
+                </a:solidFill>
+              </a:defRPr>
+            </a:pPr>
+            <a:r>
+              <a:t>      Slippery grid:        VI 145  ·  PI 7</a:t>
+            </a:r>
+          </a:p>
+          <a:p>
+            <a:pPr>
+              <a:spcAft>
+                <a:spcPts val="600"/>
+              </a:spcAft>
+              <a:defRPr sz="2000" b="0">
+                <a:solidFill>
+                  <a:srgbClr val="1F2A44"/>
+                </a:solidFill>
+              </a:defRPr>
+            </a:pPr>
+            <a:r>
+              <a:t>      Cliff Walking:         VI 15  ·  PI 15</a:t>
+            </a:r>
+          </a:p>
+          <a:p>
+            <a:pPr>
+              <a:spcAft>
+                <a:spcPts val="600"/>
+              </a:spcAft>
+              <a:defRPr sz="2000" b="0">
+                <a:solidFill>
+                  <a:srgbClr val="1F2A44"/>
+                </a:solidFill>
+              </a:defRPr>
+            </a:pPr>
+            <a:r>
+              <a:t>• VI: cheap sweeps, asymptotic convergence · PI: expensive steps, exact in a few iterations</a:t>
+            </a:r>
+          </a:p>
+        </p:txBody>
+      </p:sp>
+    </p:spTree>
+  </p:cSld>
+  <p:clrMapOvr>
+    <a:masterClrMapping/>
+  </p:clrMapOvr>
+</p:sld>
+</file>
+
+<file path=ppt/slides/slide12.xml><?xml version="1.0" encoding="utf-8"?>
 <p:sld xmlns:a="http://schemas.openxmlformats.org/drawingml/2006/main" xmlns:p="http://schemas.openxmlformats.org/presentationml/2006/main" xmlns:r="http://schemas.openxmlformats.org/officeDocument/2006/relationships">
   <p:cSld>
     <p:spTree>
@@ -5035,7 +5265,7 @@
               </a:defRPr>
             </a:pPr>
             <a:r>
-              <a:t>TPE, 40 trials, objective = area under the regret curve</a:t>
+              <a:t>Multi-objective TPE (speed vs exactness), 12 studies x 150 trials</a:t>
             </a:r>
           </a:p>
         </p:txBody>
@@ -5049,7 +5279,7 @@
         <p:spPr>
           <a:xfrm>
             <a:off x="457200" y="1463040"/>
-            <a:ext cx="3413674" cy="5029200"/>
+            <a:ext cx="3657508" cy="5029200"/>
           </a:xfrm>
           <a:prstGeom prst="rect">
             <a:avLst/>
@@ -5073,7 +5303,7 @@
               </a:defRPr>
             </a:pPr>
             <a:r>
-              <a:t>• Tuned α and the ε schedule (start, min, decay) on 5 seeds</a:t>
+              <a:t>• Speed better in all 12 cases (permutation test p&lt;0.05, 10 with p&lt;0.001, 20 held-out seeds)</a:t>
             </a:r>
           </a:p>
           <a:p>
@@ -5088,7 +5318,7 @@
               </a:defRPr>
             </a:pPr>
             <a:r>
-              <a:t>• Held-out (20 new seeds): mean regret SARSA 0.036 → 0.014, Q-learning 0.015 → 0.007</a:t>
+              <a:t>• Q-learning (slippery): 20/20 seeds optimal in 3000 episodes</a:t>
             </a:r>
           </a:p>
           <a:p>
@@ -5103,7 +5333,7 @@
               </a:defRPr>
             </a:pPr>
             <a:r>
-              <a:t>• Q-learning tuned: 19/20 seeds optimal (default 7/20)</a:t>
+              <a:t>• Expected SARSA (Cliff): 0 → 18/20 optimal</a:t>
             </a:r>
           </a:p>
           <a:p>
@@ -5118,7 +5348,7 @@
               </a:defRPr>
             </a:pPr>
             <a:r>
-              <a:t>• Over-fitting is visible: SARSA objective 0.001 on tuning seeds but 0.014 held-out</a:t>
+              <a:t>• Optuna rediscovered the theory: Robbins–Monro α in 8/10, ε → 0 (GLIE)</a:t>
             </a:r>
           </a:p>
           <a:p>
@@ -5133,14 +5363,29 @@
               </a:defRPr>
             </a:pPr>
             <a:r>
-              <a:t>• Lower regret ≠ more exact: tuned SARSA learns faster, but only 5/20 seeds reach exactly π*</a:t>
+              <a:t>• Cliff: Q-learning keeps ε=0.27 (off-policy), Expected SARSA needs ε→0 (on-policy)</a:t>
+            </a:r>
+          </a:p>
+          <a:p>
+            <a:pPr>
+              <a:spcAft>
+                <a:spcPts val="600"/>
+              </a:spcAft>
+              <a:defRPr sz="1600" b="0">
+                <a:solidFill>
+                  <a:srgbClr val="1F2A44"/>
+                </a:solidFill>
+              </a:defRPr>
+            </a:pPr>
+            <a:r>
+              <a:t>• n-step: n=1 with noisy transitions, n=4 in Cliff</a:t>
             </a:r>
           </a:p>
         </p:txBody>
       </p:sp>
       <p:pic>
         <p:nvPicPr>
-          <p:cNvPr id="6" name="Picture 5" descr="exp4_preliminary_optuna.png"/>
+          <p:cNvPr id="6" name="Picture 5" descr="exp4_default_vs_tuned.png"/>
           <p:cNvPicPr>
             <a:picLocks noChangeAspect="1"/>
           </p:cNvPicPr>
@@ -5154,8 +5399,8 @@
         </p:blipFill>
         <p:spPr>
           <a:xfrm>
-            <a:off x="3962314" y="1371600"/>
-            <a:ext cx="7863620" cy="4172182"/>
+            <a:off x="4206148" y="1371600"/>
+            <a:ext cx="7619786" cy="4072950"/>
           </a:xfrm>
           <a:prstGeom prst="rect">
             <a:avLst/>
@@ -5468,7 +5713,7 @@
               </a:defRPr>
             </a:pPr>
             <a:r>
-              <a:t>Backup: why MC and Double Q fail in Cliff Walking</a:t>
+              <a:t>Backup: Optuna Pareto fronts and parameter importance</a:t>
             </a:r>
           </a:p>
         </p:txBody>
@@ -5506,82 +5751,14 @@
               </a:defRPr>
             </a:pPr>
             <a:r>
-              <a:t>Estimates collapse to the −1/(1−γ) = −100 'never arrive' plateau</a:t>
-            </a:r>
-          </a:p>
-        </p:txBody>
-      </p:sp>
-      <p:sp>
-        <p:nvSpPr>
-          <p:cNvPr id="5" name="TextBox 4"/>
-          <p:cNvSpPr txBox="1"/>
-          <p:nvPr/>
-        </p:nvSpPr>
-        <p:spPr>
-          <a:xfrm>
-            <a:off x="457200" y="1463040"/>
-            <a:ext cx="3657508" cy="5029200"/>
-          </a:xfrm>
-          <a:prstGeom prst="rect">
-            <a:avLst/>
-          </a:prstGeom>
-          <a:noFill/>
-        </p:spPr>
-        <p:txBody>
-          <a:bodyPr wrap="square">
-            <a:spAutoFit/>
-          </a:bodyPr>
-          <a:lstStyle/>
-          <a:p>
-            <a:pPr>
-              <a:spcAft>
-                <a:spcPts val="600"/>
-              </a:spcAft>
-              <a:defRPr sz="1600" b="0">
-                <a:solidFill>
-                  <a:srgbClr val="1F2A44"/>
-                </a:solidFill>
-              </a:defRPr>
-            </a:pPr>
-            <a:r>
-              <a:t>• MC with 1/N: the −1500 returns of the first episodes stay in the mean forever (non-stationary target)</a:t>
-            </a:r>
-          </a:p>
-          <a:p>
-            <a:pPr>
-              <a:spcAft>
-                <a:spcPts val="600"/>
-              </a:spcAft>
-              <a:defRPr sz="1600" b="0">
-                <a:solidFill>
-                  <a:srgbClr val="1F2A44"/>
-                </a:solidFill>
-              </a:defRPr>
-            </a:pPr>
-            <a:r>
-              <a:t>• Constant-α MC: 14/20 stuck seeds → 0/20; exploring starts helps further</a:t>
-            </a:r>
-          </a:p>
-          <a:p>
-            <a:pPr>
-              <a:spcAft>
-                <a:spcPts val="600"/>
-              </a:spcAft>
-              <a:defRPr sz="1600" b="0">
-                <a:solidFill>
-                  <a:srgbClr val="1F2A44"/>
-                </a:solidFill>
-              </a:defRPr>
-            </a:pPr>
-            <a:r>
-              <a:t>• Double Q, α = 0.5: 3/20 seeds collapse to −100; α = 0.1 → 0/20</a:t>
+              <a:t>Speed vs exactness trade-off; which hyper-parameters matter</a:t>
             </a:r>
           </a:p>
         </p:txBody>
       </p:sp>
       <p:pic>
         <p:nvPicPr>
-          <p:cNvPr id="6" name="Picture 5" descr="exp6_failure_analysis.png"/>
+          <p:cNvPr id="5" name="Picture 4" descr="exp4_pareto.png"/>
           <p:cNvPicPr>
             <a:picLocks noChangeAspect="1"/>
           </p:cNvPicPr>
@@ -5595,8 +5772,32 @@
         </p:blipFill>
         <p:spPr>
           <a:xfrm>
-            <a:off x="4206148" y="1371600"/>
-            <a:ext cx="7619786" cy="2543639"/>
+            <a:off x="2034227" y="1280160"/>
+            <a:ext cx="8123241" cy="2651760"/>
+          </a:xfrm>
+          <a:prstGeom prst="rect">
+            <a:avLst/>
+          </a:prstGeom>
+        </p:spPr>
+      </p:pic>
+      <p:pic>
+        <p:nvPicPr>
+          <p:cNvPr id="6" name="Picture 5" descr="exp4_param_importance.png"/>
+          <p:cNvPicPr>
+            <a:picLocks noChangeAspect="1"/>
+          </p:cNvPicPr>
+          <p:nvPr/>
+        </p:nvPicPr>
+        <p:blipFill>
+          <a:blip r:embed="rId3"/>
+          <a:stretch>
+            <a:fillRect/>
+          </a:stretch>
+        </p:blipFill>
+        <p:spPr>
+          <a:xfrm>
+            <a:off x="2732738" y="3977639"/>
+            <a:ext cx="6726218" cy="2788920"/>
           </a:xfrm>
           <a:prstGeom prst="rect">
             <a:avLst/>

</xml_diff>